<commit_message>
Fix overlapping text and add slide transitions to the video deck
Slides 3-5 had the concept-tag badge overlapping the slide title, and
slide 2's step labels could collide with the note text below them under
wider Arabic font substitution (e.g. on iOS PowerPoint). Widened boxes,
fixed vertical spacing, and added a native fade transition to every
slide so playback isn't an abrupt cut.

Co-Authored-By: Claude Sonnet 5 <noreply@anthropic.com>
Claude-Session: https://claude.ai/code/session_017UcE2n68wNPrKjbMuUe2cw
</commit_message>
<xml_diff>
--- a/saif-competition-materials/03-video/athar-presentation.pptx
+++ b/saif-competition-materials/03-video/athar-presentation.pptx
@@ -1846,6 +1846,9 @@
       </p:sp>
     </p:spTree>
   </p:cSld>
+  <p:transition spd="med">
+    <p:fade/>
+  </p:transition>
   <p:clrMapOvr>
     <a:masterClrMapping/>
   </p:clrMapOvr>
@@ -2002,11 +2005,11 @@
         <p:spPr>
           <a:xfrm>
             <a:off x="632308" y="2377440"/>
-            <a:ext cx="10927080" cy="2880360"/>
+            <a:ext cx="10927080" cy="3200400"/>
           </a:xfrm>
           <a:prstGeom prst="roundRect">
             <a:avLst>
-              <a:gd name="adj" fmla="val 3810"/>
+              <a:gd name="adj" fmla="val 3429"/>
             </a:avLst>
           </a:prstGeom>
           <a:solidFill>
@@ -2094,24 +2097,27 @@
         </p:nvSpPr>
         <p:spPr>
           <a:xfrm>
-            <a:off x="9364828" y="3931920"/>
-            <a:ext cx="1874520" cy="457200"/>
-          </a:xfrm>
-          <a:prstGeom prst="rect">
-            <a:avLst/>
-          </a:prstGeom>
-          <a:noFill/>
-          <a:ln/>
-        </p:spPr>
-        <p:txBody>
-          <a:bodyPr wrap="square" lIns="0" tIns="0" rIns="0" bIns="0" rtlCol="0" anchor="ctr"/>
+            <a:off x="9337396" y="3886200"/>
+            <a:ext cx="1929384" cy="822960"/>
+          </a:xfrm>
+          <a:prstGeom prst="rect">
+            <a:avLst/>
+          </a:prstGeom>
+          <a:noFill/>
+          <a:ln/>
+        </p:spPr>
+        <p:txBody>
+          <a:bodyPr wrap="square" lIns="0" tIns="0" rIns="0" bIns="0" rtlCol="0" anchor="t"/>
           <a:lstStyle/>
           <a:p>
             <a:pPr rtl="1" algn="ctr" indent="0" marL="0">
-              <a:buNone/>
-            </a:pPr>
-            <a:r>
-              <a:rPr lang="en-US" sz="1400" b="1" dirty="0">
+              <a:lnSpc>
+                <a:spcPct val="115000"/>
+              </a:lnSpc>
+              <a:buNone/>
+            </a:pPr>
+            <a:r>
+              <a:rPr lang="en-US" sz="1250" b="1" dirty="0">
                 <a:solidFill>
                   <a:srgbClr val="0B1F3A"/>
                 </a:solidFill>
@@ -2121,7 +2127,7 @@
               </a:rPr>
               <a:t>تسجيل الرحلة</a:t>
             </a:r>
-            <a:endParaRPr lang="en-US" sz="1400" dirty="0"/>
+            <a:endParaRPr lang="en-US" sz="1250" dirty="0"/>
           </a:p>
         </p:txBody>
       </p:sp>
@@ -2231,24 +2237,27 @@
         </p:nvSpPr>
         <p:spPr>
           <a:xfrm>
-            <a:off x="7261708" y="3931920"/>
-            <a:ext cx="1874520" cy="457200"/>
-          </a:xfrm>
-          <a:prstGeom prst="rect">
-            <a:avLst/>
-          </a:prstGeom>
-          <a:noFill/>
-          <a:ln/>
-        </p:spPr>
-        <p:txBody>
-          <a:bodyPr wrap="square" lIns="0" tIns="0" rIns="0" bIns="0" rtlCol="0" anchor="ctr"/>
+            <a:off x="7234276" y="3886200"/>
+            <a:ext cx="1929384" cy="822960"/>
+          </a:xfrm>
+          <a:prstGeom prst="rect">
+            <a:avLst/>
+          </a:prstGeom>
+          <a:noFill/>
+          <a:ln/>
+        </p:spPr>
+        <p:txBody>
+          <a:bodyPr wrap="square" lIns="0" tIns="0" rIns="0" bIns="0" rtlCol="0" anchor="t"/>
           <a:lstStyle/>
           <a:p>
             <a:pPr rtl="1" algn="ctr" indent="0" marL="0">
-              <a:buNone/>
-            </a:pPr>
-            <a:r>
-              <a:rPr lang="en-US" sz="1400" b="1" dirty="0">
+              <a:lnSpc>
+                <a:spcPct val="115000"/>
+              </a:lnSpc>
+              <a:buNone/>
+            </a:pPr>
+            <a:r>
+              <a:rPr lang="en-US" sz="1250" b="1" dirty="0">
                 <a:solidFill>
                   <a:srgbClr val="0B1F3A"/>
                 </a:solidFill>
@@ -2258,7 +2267,7 @@
               </a:rPr>
               <a:t>حفظ المواقع</a:t>
             </a:r>
-            <a:endParaRPr lang="en-US" sz="1400" dirty="0"/>
+            <a:endParaRPr lang="en-US" sz="1250" dirty="0"/>
           </a:p>
         </p:txBody>
       </p:sp>
@@ -2368,24 +2377,27 @@
         </p:nvSpPr>
         <p:spPr>
           <a:xfrm>
-            <a:off x="5158588" y="3931920"/>
-            <a:ext cx="1874520" cy="457200"/>
-          </a:xfrm>
-          <a:prstGeom prst="rect">
-            <a:avLst/>
-          </a:prstGeom>
-          <a:noFill/>
-          <a:ln/>
-        </p:spPr>
-        <p:txBody>
-          <a:bodyPr wrap="square" lIns="0" tIns="0" rIns="0" bIns="0" rtlCol="0" anchor="ctr"/>
+            <a:off x="5131156" y="3886200"/>
+            <a:ext cx="1929384" cy="822960"/>
+          </a:xfrm>
+          <a:prstGeom prst="rect">
+            <a:avLst/>
+          </a:prstGeom>
+          <a:noFill/>
+          <a:ln/>
+        </p:spPr>
+        <p:txBody>
+          <a:bodyPr wrap="square" lIns="0" tIns="0" rIns="0" bIns="0" rtlCol="0" anchor="t"/>
           <a:lstStyle/>
           <a:p>
             <a:pPr rtl="1" algn="ctr" indent="0" marL="0">
-              <a:buNone/>
-            </a:pPr>
-            <a:r>
-              <a:rPr lang="en-US" sz="1400" b="1" dirty="0">
+              <a:lnSpc>
+                <a:spcPct val="115000"/>
+              </a:lnSpc>
+              <a:buNone/>
+            </a:pPr>
+            <a:r>
+              <a:rPr lang="en-US" sz="1250" b="1" dirty="0">
                 <a:solidFill>
                   <a:srgbClr val="0B1F3A"/>
                 </a:solidFill>
@@ -2395,7 +2407,7 @@
               </a:rPr>
               <a:t>تجاوز الموعد</a:t>
             </a:r>
-            <a:endParaRPr lang="en-US" sz="1400" dirty="0"/>
+            <a:endParaRPr lang="en-US" sz="1250" dirty="0"/>
           </a:p>
         </p:txBody>
       </p:sp>
@@ -2505,24 +2517,27 @@
         </p:nvSpPr>
         <p:spPr>
           <a:xfrm>
-            <a:off x="3055468" y="3931920"/>
-            <a:ext cx="1874520" cy="457200"/>
-          </a:xfrm>
-          <a:prstGeom prst="rect">
-            <a:avLst/>
-          </a:prstGeom>
-          <a:noFill/>
-          <a:ln/>
-        </p:spPr>
-        <p:txBody>
-          <a:bodyPr wrap="square" lIns="0" tIns="0" rIns="0" bIns="0" rtlCol="0" anchor="ctr"/>
+            <a:off x="3028036" y="3886200"/>
+            <a:ext cx="1929384" cy="822960"/>
+          </a:xfrm>
+          <a:prstGeom prst="rect">
+            <a:avLst/>
+          </a:prstGeom>
+          <a:noFill/>
+          <a:ln/>
+        </p:spPr>
+        <p:txBody>
+          <a:bodyPr wrap="square" lIns="0" tIns="0" rIns="0" bIns="0" rtlCol="0" anchor="t"/>
           <a:lstStyle/>
           <a:p>
             <a:pPr rtl="1" algn="ctr" indent="0" marL="0">
-              <a:buNone/>
-            </a:pPr>
-            <a:r>
-              <a:rPr lang="en-US" sz="1400" b="1" dirty="0">
+              <a:lnSpc>
+                <a:spcPct val="115000"/>
+              </a:lnSpc>
+              <a:buNone/>
+            </a:pPr>
+            <a:r>
+              <a:rPr lang="en-US" sz="1250" b="1" dirty="0">
                 <a:solidFill>
                   <a:srgbClr val="0B1F3A"/>
                 </a:solidFill>
@@ -2532,7 +2547,7 @@
               </a:rPr>
               <a:t>تنبيه فوري</a:t>
             </a:r>
-            <a:endParaRPr lang="en-US" sz="1400" dirty="0"/>
+            <a:endParaRPr lang="en-US" sz="1250" dirty="0"/>
           </a:p>
         </p:txBody>
       </p:sp>
@@ -2642,24 +2657,27 @@
         </p:nvSpPr>
         <p:spPr>
           <a:xfrm>
-            <a:off x="952348" y="3931920"/>
-            <a:ext cx="1874520" cy="457200"/>
-          </a:xfrm>
-          <a:prstGeom prst="rect">
-            <a:avLst/>
-          </a:prstGeom>
-          <a:noFill/>
-          <a:ln/>
-        </p:spPr>
-        <p:txBody>
-          <a:bodyPr wrap="square" lIns="0" tIns="0" rIns="0" bIns="0" rtlCol="0" anchor="ctr"/>
+            <a:off x="924916" y="3886200"/>
+            <a:ext cx="1929384" cy="822960"/>
+          </a:xfrm>
+          <a:prstGeom prst="rect">
+            <a:avLst/>
+          </a:prstGeom>
+          <a:noFill/>
+          <a:ln/>
+        </p:spPr>
+        <p:txBody>
+          <a:bodyPr wrap="square" lIns="0" tIns="0" rIns="0" bIns="0" rtlCol="0" anchor="t"/>
           <a:lstStyle/>
           <a:p>
             <a:pPr rtl="1" algn="ctr" indent="0" marL="0">
-              <a:buNone/>
-            </a:pPr>
-            <a:r>
-              <a:rPr lang="en-US" sz="1400" b="1" dirty="0">
+              <a:lnSpc>
+                <a:spcPct val="115000"/>
+              </a:lnSpc>
+              <a:buNone/>
+            </a:pPr>
+            <a:r>
+              <a:rPr lang="en-US" sz="1250" b="1" dirty="0">
                 <a:solidFill>
                   <a:srgbClr val="0B1F3A"/>
                 </a:solidFill>
@@ -2669,7 +2687,7 @@
               </a:rPr>
               <a:t>اقتراح مناطق البحث</a:t>
             </a:r>
-            <a:endParaRPr lang="en-US" sz="1400" dirty="0"/>
+            <a:endParaRPr lang="en-US" sz="1250" dirty="0"/>
           </a:p>
         </p:txBody>
       </p:sp>
@@ -2681,8 +2699,8 @@
         </p:nvSpPr>
         <p:spPr>
           <a:xfrm>
-            <a:off x="632308" y="4617720"/>
-            <a:ext cx="10927080" cy="548640"/>
+            <a:off x="632308" y="5074920"/>
+            <a:ext cx="10927080" cy="457200"/>
           </a:xfrm>
           <a:prstGeom prst="rect">
             <a:avLst/>
@@ -2698,7 +2716,7 @@
               <a:buNone/>
             </a:pPr>
             <a:r>
-              <a:rPr lang="en-US" sz="1250" i="1" dirty="0">
+              <a:rPr lang="en-US" sz="1200" i="1" dirty="0">
                 <a:solidFill>
                   <a:srgbClr val="5A6B87"/>
                 </a:solidFill>
@@ -2708,7 +2726,7 @@
               </a:rPr>
               <a:t>يستخدم الذكاء الاصطناعي عند الحاجة لاقتراح مناطق البحث وترتيب أولوياتها — وليس للتتبع المباشر بعد انقطاع الاتصال</a:t>
             </a:r>
-            <a:endParaRPr lang="en-US" sz="1250" dirty="0"/>
+            <a:endParaRPr lang="en-US" sz="1200" dirty="0"/>
           </a:p>
         </p:txBody>
       </p:sp>
@@ -2792,6 +2810,9 @@
       </p:sp>
     </p:spTree>
   </p:cSld>
+  <p:transition spd="med">
+    <p:fade/>
+  </p:transition>
   <p:clrMapOvr>
     <a:masterClrMapping/>
   </p:clrMapOvr>
@@ -2870,7 +2891,7 @@
         <p:spPr>
           <a:xfrm>
             <a:off x="640080" y="868680"/>
-            <a:ext cx="10911535" cy="731520"/>
+            <a:ext cx="10911535" cy="502920"/>
           </a:xfrm>
           <a:prstGeom prst="rect">
             <a:avLst/>
@@ -2908,12 +2929,12 @@
         </p:nvSpPr>
         <p:spPr>
           <a:xfrm>
-            <a:off x="3169768" y="1783080"/>
-            <a:ext cx="5852160" cy="3794760"/>
+            <a:off x="3169768" y="1874520"/>
+            <a:ext cx="5852160" cy="4206240"/>
           </a:xfrm>
           <a:prstGeom prst="roundRect">
             <a:avLst>
-              <a:gd name="adj" fmla="val 2892"/>
+              <a:gd name="adj" fmla="val 2609"/>
             </a:avLst>
           </a:prstGeom>
           <a:solidFill>
@@ -2942,7 +2963,7 @@
         </p:nvSpPr>
         <p:spPr>
           <a:xfrm>
-            <a:off x="3489808" y="2057400"/>
+            <a:off x="3489808" y="2148840"/>
             <a:ext cx="5212080" cy="502920"/>
           </a:xfrm>
           <a:prstGeom prst="roundRect">
@@ -2964,7 +2985,7 @@
         </p:nvSpPr>
         <p:spPr>
           <a:xfrm>
-            <a:off x="3672688" y="2057400"/>
+            <a:off x="3672688" y="2148840"/>
             <a:ext cx="4846320" cy="502920"/>
           </a:xfrm>
           <a:prstGeom prst="rect">
@@ -3003,7 +3024,7 @@
         </p:nvSpPr>
         <p:spPr>
           <a:xfrm>
-            <a:off x="8176108" y="2811780"/>
+            <a:off x="8176108" y="2994660"/>
             <a:ext cx="502920" cy="502920"/>
           </a:xfrm>
           <a:prstGeom prst="ellipse">
@@ -3023,8 +3044,8 @@
         </p:nvSpPr>
         <p:spPr>
           <a:xfrm>
-            <a:off x="3489808" y="2743200"/>
-            <a:ext cx="4663440" cy="320040"/>
+            <a:off x="3489808" y="2880360"/>
+            <a:ext cx="4663440" cy="274320"/>
           </a:xfrm>
           <a:prstGeom prst="rect">
             <a:avLst/>
@@ -3040,7 +3061,7 @@
               <a:buNone/>
             </a:pPr>
             <a:r>
-              <a:rPr lang="en-US" sz="1200" dirty="0">
+              <a:rPr lang="en-US" sz="1150" dirty="0">
                 <a:solidFill>
                   <a:srgbClr val="5A6B87"/>
                 </a:solidFill>
@@ -3050,7 +3071,7 @@
               </a:rPr>
               <a:t>الوجهة</a:t>
             </a:r>
-            <a:endParaRPr lang="en-US" sz="1200" dirty="0"/>
+            <a:endParaRPr lang="en-US" sz="1150" dirty="0"/>
           </a:p>
         </p:txBody>
       </p:sp>
@@ -3062,8 +3083,8 @@
         </p:nvSpPr>
         <p:spPr>
           <a:xfrm>
-            <a:off x="3489808" y="3044952"/>
-            <a:ext cx="4663440" cy="365760"/>
+            <a:off x="3489808" y="3154680"/>
+            <a:ext cx="4663440" cy="457200"/>
           </a:xfrm>
           <a:prstGeom prst="rect">
             <a:avLst/>
@@ -3076,10 +3097,13 @@
           <a:lstStyle/>
           <a:p>
             <a:pPr rtl="1" algn="r" indent="0" marL="0">
-              <a:buNone/>
-            </a:pPr>
-            <a:r>
-              <a:rPr lang="en-US" sz="1550" b="1" dirty="0">
+              <a:lnSpc>
+                <a:spcPct val="115000"/>
+              </a:lnSpc>
+              <a:buNone/>
+            </a:pPr>
+            <a:r>
+              <a:rPr lang="en-US" sz="1450" b="1" dirty="0">
                 <a:solidFill>
                   <a:srgbClr val="0B1F3A"/>
                 </a:solidFill>
@@ -3089,7 +3113,7 @@
               </a:rPr>
               <a:t>واحة الشعيب — طريق ٤١٢ البري</a:t>
             </a:r>
-            <a:endParaRPr lang="en-US" sz="1550" dirty="0"/>
+            <a:endParaRPr lang="en-US" sz="1450" dirty="0"/>
           </a:p>
         </p:txBody>
       </p:sp>
@@ -3101,7 +3125,7 @@
         </p:nvSpPr>
         <p:spPr>
           <a:xfrm>
-            <a:off x="8176108" y="3515868"/>
+            <a:off x="8176108" y="3771900"/>
             <a:ext cx="502920" cy="502920"/>
           </a:xfrm>
           <a:prstGeom prst="ellipse">
@@ -3121,8 +3145,8 @@
         </p:nvSpPr>
         <p:spPr>
           <a:xfrm>
-            <a:off x="3489808" y="3447288"/>
-            <a:ext cx="4663440" cy="320040"/>
+            <a:off x="3489808" y="3657600"/>
+            <a:ext cx="4663440" cy="274320"/>
           </a:xfrm>
           <a:prstGeom prst="rect">
             <a:avLst/>
@@ -3138,7 +3162,7 @@
               <a:buNone/>
             </a:pPr>
             <a:r>
-              <a:rPr lang="en-US" sz="1200" dirty="0">
+              <a:rPr lang="en-US" sz="1150" dirty="0">
                 <a:solidFill>
                   <a:srgbClr val="5A6B87"/>
                 </a:solidFill>
@@ -3148,7 +3172,7 @@
               </a:rPr>
               <a:t>موعد الاطمئنان القادم</a:t>
             </a:r>
-            <a:endParaRPr lang="en-US" sz="1200" dirty="0"/>
+            <a:endParaRPr lang="en-US" sz="1150" dirty="0"/>
           </a:p>
         </p:txBody>
       </p:sp>
@@ -3160,8 +3184,8 @@
         </p:nvSpPr>
         <p:spPr>
           <a:xfrm>
-            <a:off x="3489808" y="3749040"/>
-            <a:ext cx="4663440" cy="365760"/>
+            <a:off x="3489808" y="3931920"/>
+            <a:ext cx="4663440" cy="457200"/>
           </a:xfrm>
           <a:prstGeom prst="rect">
             <a:avLst/>
@@ -3174,10 +3198,13 @@
           <a:lstStyle/>
           <a:p>
             <a:pPr rtl="1" algn="r" indent="0" marL="0">
-              <a:buNone/>
-            </a:pPr>
-            <a:r>
-              <a:rPr lang="en-US" sz="1550" b="1" dirty="0">
+              <a:lnSpc>
+                <a:spcPct val="115000"/>
+              </a:lnSpc>
+              <a:buNone/>
+            </a:pPr>
+            <a:r>
+              <a:rPr lang="en-US" sz="1450" b="1" dirty="0">
                 <a:solidFill>
                   <a:srgbClr val="0B1F3A"/>
                 </a:solidFill>
@@ -3187,7 +3214,7 @@
               </a:rPr>
               <a:t>اليوم — الساعة ٨:٠٠ مساءً</a:t>
             </a:r>
-            <a:endParaRPr lang="en-US" sz="1550" dirty="0"/>
+            <a:endParaRPr lang="en-US" sz="1450" dirty="0"/>
           </a:p>
         </p:txBody>
       </p:sp>
@@ -3199,7 +3226,7 @@
         </p:nvSpPr>
         <p:spPr>
           <a:xfrm>
-            <a:off x="8176108" y="4219956"/>
+            <a:off x="8176108" y="4549140"/>
             <a:ext cx="502920" cy="502920"/>
           </a:xfrm>
           <a:prstGeom prst="ellipse">
@@ -3219,8 +3246,8 @@
         </p:nvSpPr>
         <p:spPr>
           <a:xfrm>
-            <a:off x="3489808" y="4151376"/>
-            <a:ext cx="4663440" cy="320040"/>
+            <a:off x="3489808" y="4434840"/>
+            <a:ext cx="4663440" cy="274320"/>
           </a:xfrm>
           <a:prstGeom prst="rect">
             <a:avLst/>
@@ -3236,7 +3263,7 @@
               <a:buNone/>
             </a:pPr>
             <a:r>
-              <a:rPr lang="en-US" sz="1200" dirty="0">
+              <a:rPr lang="en-US" sz="1150" dirty="0">
                 <a:solidFill>
                   <a:srgbClr val="5A6B87"/>
                 </a:solidFill>
@@ -3246,7 +3273,7 @@
               </a:rPr>
               <a:t>الشخص الموثوق للمتابعة</a:t>
             </a:r>
-            <a:endParaRPr lang="en-US" sz="1200" dirty="0"/>
+            <a:endParaRPr lang="en-US" sz="1150" dirty="0"/>
           </a:p>
         </p:txBody>
       </p:sp>
@@ -3258,8 +3285,8 @@
         </p:nvSpPr>
         <p:spPr>
           <a:xfrm>
-            <a:off x="3489808" y="4453128"/>
-            <a:ext cx="4663440" cy="365760"/>
+            <a:off x="3489808" y="4709160"/>
+            <a:ext cx="4663440" cy="457200"/>
           </a:xfrm>
           <a:prstGeom prst="rect">
             <a:avLst/>
@@ -3272,10 +3299,13 @@
           <a:lstStyle/>
           <a:p>
             <a:pPr rtl="1" algn="r" indent="0" marL="0">
-              <a:buNone/>
-            </a:pPr>
-            <a:r>
-              <a:rPr lang="en-US" sz="1550" b="1" dirty="0">
+              <a:lnSpc>
+                <a:spcPct val="115000"/>
+              </a:lnSpc>
+              <a:buNone/>
+            </a:pPr>
+            <a:r>
+              <a:rPr lang="en-US" sz="1450" b="1" dirty="0">
                 <a:solidFill>
                   <a:srgbClr val="0B1F3A"/>
                 </a:solidFill>
@@ -3285,7 +3315,7 @@
               </a:rPr>
               <a:t>سالم العتيبي — أخ المسافر</a:t>
             </a:r>
-            <a:endParaRPr lang="en-US" sz="1550" dirty="0"/>
+            <a:endParaRPr lang="en-US" sz="1450" dirty="0"/>
           </a:p>
         </p:txBody>
       </p:sp>
@@ -3297,7 +3327,7 @@
         </p:nvSpPr>
         <p:spPr>
           <a:xfrm>
-            <a:off x="8176108" y="4924044"/>
+            <a:off x="8176108" y="5326380"/>
             <a:ext cx="502920" cy="502920"/>
           </a:xfrm>
           <a:prstGeom prst="ellipse">
@@ -3317,8 +3347,8 @@
         </p:nvSpPr>
         <p:spPr>
           <a:xfrm>
-            <a:off x="3489808" y="4855464"/>
-            <a:ext cx="4663440" cy="320040"/>
+            <a:off x="3489808" y="5212080"/>
+            <a:ext cx="4663440" cy="274320"/>
           </a:xfrm>
           <a:prstGeom prst="rect">
             <a:avLst/>
@@ -3334,7 +3364,7 @@
               <a:buNone/>
             </a:pPr>
             <a:r>
-              <a:rPr lang="en-US" sz="1200" dirty="0">
+              <a:rPr lang="en-US" sz="1150" dirty="0">
                 <a:solidFill>
                   <a:srgbClr val="5A6B87"/>
                 </a:solidFill>
@@ -3344,7 +3374,7 @@
               </a:rPr>
               <a:t>المركبة والركاب</a:t>
             </a:r>
-            <a:endParaRPr lang="en-US" sz="1200" dirty="0"/>
+            <a:endParaRPr lang="en-US" sz="1150" dirty="0"/>
           </a:p>
         </p:txBody>
       </p:sp>
@@ -3356,8 +3386,8 @@
         </p:nvSpPr>
         <p:spPr>
           <a:xfrm>
-            <a:off x="3489808" y="5157216"/>
-            <a:ext cx="4663440" cy="365760"/>
+            <a:off x="3489808" y="5486400"/>
+            <a:ext cx="4663440" cy="457200"/>
           </a:xfrm>
           <a:prstGeom prst="rect">
             <a:avLst/>
@@ -3370,10 +3400,13 @@
           <a:lstStyle/>
           <a:p>
             <a:pPr rtl="1" algn="r" indent="0" marL="0">
-              <a:buNone/>
-            </a:pPr>
-            <a:r>
-              <a:rPr lang="en-US" sz="1550" b="1" dirty="0">
+              <a:lnSpc>
+                <a:spcPct val="115000"/>
+              </a:lnSpc>
+              <a:buNone/>
+            </a:pPr>
+            <a:r>
+              <a:rPr lang="en-US" sz="1450" b="1" dirty="0">
                 <a:solidFill>
                   <a:srgbClr val="0B1F3A"/>
                 </a:solidFill>
@@ -3383,7 +3416,7 @@
               </a:rPr>
               <a:t>دفع رباعي أبيض — ٣ ركاب</a:t>
             </a:r>
-            <a:endParaRPr lang="en-US" sz="1550" dirty="0"/>
+            <a:endParaRPr lang="en-US" sz="1450" dirty="0"/>
           </a:p>
         </p:txBody>
       </p:sp>
@@ -3395,7 +3428,7 @@
         </p:nvSpPr>
         <p:spPr>
           <a:xfrm>
-            <a:off x="6644488" y="1280160"/>
+            <a:off x="6644488" y="1444752"/>
             <a:ext cx="2377440" cy="365760"/>
           </a:xfrm>
           <a:prstGeom prst="roundRect">
@@ -3417,7 +3450,7 @@
         </p:nvSpPr>
         <p:spPr>
           <a:xfrm>
-            <a:off x="6644488" y="1280160"/>
+            <a:off x="6644488" y="1444752"/>
             <a:ext cx="2377440" cy="365760"/>
           </a:xfrm>
           <a:prstGeom prst="rect">
@@ -3528,6 +3561,9 @@
       </p:sp>
     </p:spTree>
   </p:cSld>
+  <p:transition spd="med">
+    <p:fade/>
+  </p:transition>
   <p:clrMapOvr>
     <a:masterClrMapping/>
   </p:clrMapOvr>
@@ -3606,7 +3642,7 @@
         <p:spPr>
           <a:xfrm>
             <a:off x="640080" y="868680"/>
-            <a:ext cx="10911535" cy="731520"/>
+            <a:ext cx="10911535" cy="502920"/>
           </a:xfrm>
           <a:prstGeom prst="rect">
             <a:avLst/>
@@ -3644,12 +3680,12 @@
         </p:nvSpPr>
         <p:spPr>
           <a:xfrm>
-            <a:off x="3078328" y="1783080"/>
-            <a:ext cx="6035040" cy="3794760"/>
+            <a:off x="3078328" y="1874520"/>
+            <a:ext cx="6035040" cy="3931920"/>
           </a:xfrm>
           <a:prstGeom prst="roundRect">
             <a:avLst>
-              <a:gd name="adj" fmla="val 2892"/>
+              <a:gd name="adj" fmla="val 2791"/>
             </a:avLst>
           </a:prstGeom>
           <a:solidFill>
@@ -3678,7 +3714,7 @@
         </p:nvSpPr>
         <p:spPr>
           <a:xfrm>
-            <a:off x="3398368" y="2057400"/>
+            <a:off x="3398368" y="2148840"/>
             <a:ext cx="5394960" cy="502920"/>
           </a:xfrm>
           <a:prstGeom prst="roundRect">
@@ -3700,7 +3736,7 @@
         </p:nvSpPr>
         <p:spPr>
           <a:xfrm>
-            <a:off x="3581248" y="2057400"/>
+            <a:off x="3581248" y="2148840"/>
             <a:ext cx="5029200" cy="502920"/>
           </a:xfrm>
           <a:prstGeom prst="rect">
@@ -3739,12 +3775,12 @@
         </p:nvSpPr>
         <p:spPr>
           <a:xfrm>
-            <a:off x="3398368" y="2743200"/>
-            <a:ext cx="5394960" cy="914400"/>
+            <a:off x="3398368" y="2834640"/>
+            <a:ext cx="5394960" cy="1051560"/>
           </a:xfrm>
           <a:prstGeom prst="roundRect">
             <a:avLst>
-              <a:gd name="adj" fmla="val 10000"/>
+              <a:gd name="adj" fmla="val 8696"/>
             </a:avLst>
           </a:prstGeom>
           <a:solidFill>
@@ -3766,7 +3802,7 @@
         </p:nvSpPr>
         <p:spPr>
           <a:xfrm>
-            <a:off x="8198968" y="2971800"/>
+            <a:off x="8198968" y="3131820"/>
             <a:ext cx="457200" cy="457200"/>
           </a:xfrm>
           <a:prstGeom prst="ellipse">
@@ -3786,7 +3822,7 @@
         </p:nvSpPr>
         <p:spPr>
           <a:xfrm>
-            <a:off x="8198968" y="2971800"/>
+            <a:off x="8198968" y="3131820"/>
             <a:ext cx="457200" cy="457200"/>
           </a:xfrm>
           <a:prstGeom prst="rect">
@@ -3825,8 +3861,8 @@
         </p:nvSpPr>
         <p:spPr>
           <a:xfrm>
-            <a:off x="3581248" y="2862072"/>
-            <a:ext cx="4663440" cy="320040"/>
+            <a:off x="3581248" y="2953512"/>
+            <a:ext cx="4663440" cy="457200"/>
           </a:xfrm>
           <a:prstGeom prst="rect">
             <a:avLst/>
@@ -3839,10 +3875,13 @@
           <a:lstStyle/>
           <a:p>
             <a:pPr rtl="1" algn="r" indent="0" marL="0">
-              <a:buNone/>
-            </a:pPr>
-            <a:r>
-              <a:rPr lang="en-US" sz="1450" b="1" dirty="0">
+              <a:lnSpc>
+                <a:spcPct val="110000"/>
+              </a:lnSpc>
+              <a:buNone/>
+            </a:pPr>
+            <a:r>
+              <a:rPr lang="en-US" sz="1400" b="1" dirty="0">
                 <a:solidFill>
                   <a:srgbClr val="0B1F3A"/>
                 </a:solidFill>
@@ -3852,7 +3891,7 @@
               </a:rPr>
               <a:t>تنبيه: سالم لم يؤكد سلامته بعد موعد اطمئنانه</a:t>
             </a:r>
-            <a:endParaRPr lang="en-US" sz="1450" dirty="0"/>
+            <a:endParaRPr lang="en-US" sz="1400" dirty="0"/>
           </a:p>
         </p:txBody>
       </p:sp>
@@ -3864,8 +3903,8 @@
         </p:nvSpPr>
         <p:spPr>
           <a:xfrm>
-            <a:off x="3581248" y="3200400"/>
-            <a:ext cx="4663440" cy="320040"/>
+            <a:off x="3581248" y="3447288"/>
+            <a:ext cx="4663440" cy="365760"/>
           </a:xfrm>
           <a:prstGeom prst="rect">
             <a:avLst/>
@@ -3881,7 +3920,7 @@
               <a:buNone/>
             </a:pPr>
             <a:r>
-              <a:rPr lang="en-US" sz="1200" dirty="0">
+              <a:rPr lang="en-US" sz="1150" dirty="0">
                 <a:solidFill>
                   <a:srgbClr val="5A6B87"/>
                 </a:solidFill>
@@ -3891,7 +3930,7 @@
               </a:rPr>
               <a:t>آخر تحديث موقع: قبل ٣ ساعات و٤٠ دقيقة — بيانات تجريبية</a:t>
             </a:r>
-            <a:endParaRPr lang="en-US" sz="1200" dirty="0"/>
+            <a:endParaRPr lang="en-US" sz="1150" dirty="0"/>
           </a:p>
         </p:txBody>
       </p:sp>
@@ -3903,7 +3942,7 @@
         </p:nvSpPr>
         <p:spPr>
           <a:xfrm>
-            <a:off x="3398368" y="3886200"/>
+            <a:off x="3398368" y="4114800"/>
             <a:ext cx="5394960" cy="1463040"/>
           </a:xfrm>
           <a:prstGeom prst="rect">
@@ -3923,7 +3962,7 @@
               <a:buNone/>
             </a:pPr>
             <a:r>
-              <a:rPr lang="en-US" sz="1450" dirty="0">
+              <a:rPr lang="en-US" sz="1400" dirty="0">
                 <a:solidFill>
                   <a:srgbClr val="0B1F3A"/>
                 </a:solidFill>
@@ -3933,7 +3972,7 @@
               </a:rPr>
               <a:t>يستمر التطبيق بإرسال آخر المواقع تلقائيًا أثناء توفر الاتصال، وعند تجاوز المهلة المحددة يصل التنبيه للشخص المسؤول فورًا — حتى إن كان هاتف المسافر خارج التغطية في تلك اللحظة.</a:t>
             </a:r>
-            <a:endParaRPr lang="en-US" sz="1450" dirty="0"/>
+            <a:endParaRPr lang="en-US" sz="1400" dirty="0"/>
           </a:p>
         </p:txBody>
       </p:sp>
@@ -3945,7 +3984,7 @@
         </p:nvSpPr>
         <p:spPr>
           <a:xfrm>
-            <a:off x="6735928" y="1280160"/>
+            <a:off x="6735928" y="1444752"/>
             <a:ext cx="2377440" cy="365760"/>
           </a:xfrm>
           <a:prstGeom prst="roundRect">
@@ -3967,7 +4006,7 @@
         </p:nvSpPr>
         <p:spPr>
           <a:xfrm>
-            <a:off x="6735928" y="1280160"/>
+            <a:off x="6735928" y="1444752"/>
             <a:ext cx="2377440" cy="365760"/>
           </a:xfrm>
           <a:prstGeom prst="rect">
@@ -4078,6 +4117,9 @@
       </p:sp>
     </p:spTree>
   </p:cSld>
+  <p:transition spd="med">
+    <p:fade/>
+  </p:transition>
   <p:clrMapOvr>
     <a:masterClrMapping/>
   </p:clrMapOvr>
@@ -4156,7 +4198,7 @@
         <p:spPr>
           <a:xfrm>
             <a:off x="640080" y="868680"/>
-            <a:ext cx="10911535" cy="731520"/>
+            <a:ext cx="10911535" cy="502920"/>
           </a:xfrm>
           <a:prstGeom prst="rect">
             <a:avLst/>
@@ -4194,12 +4236,12 @@
         </p:nvSpPr>
         <p:spPr>
           <a:xfrm>
-            <a:off x="2712568" y="1783080"/>
-            <a:ext cx="6766560" cy="3794760"/>
+            <a:off x="2712568" y="1874520"/>
+            <a:ext cx="6766560" cy="4297680"/>
           </a:xfrm>
           <a:prstGeom prst="roundRect">
             <a:avLst>
-              <a:gd name="adj" fmla="val 2892"/>
+              <a:gd name="adj" fmla="val 2553"/>
             </a:avLst>
           </a:prstGeom>
           <a:solidFill>
@@ -4228,7 +4270,7 @@
         </p:nvSpPr>
         <p:spPr>
           <a:xfrm>
-            <a:off x="3078328" y="2057400"/>
+            <a:off x="3078328" y="2148840"/>
             <a:ext cx="6035040" cy="411480"/>
           </a:xfrm>
           <a:prstGeom prst="rect">
@@ -4267,8 +4309,8 @@
         </p:nvSpPr>
         <p:spPr>
           <a:xfrm>
-            <a:off x="3078328" y="2743200"/>
-            <a:ext cx="2377440" cy="384048"/>
+            <a:off x="3078328" y="2807208"/>
+            <a:ext cx="2103120" cy="274320"/>
           </a:xfrm>
           <a:prstGeom prst="rect">
             <a:avLst/>
@@ -4284,7 +4326,7 @@
               <a:buNone/>
             </a:pPr>
             <a:r>
-              <a:rPr lang="en-US" sz="1250" dirty="0">
+              <a:rPr lang="en-US" sz="1150" dirty="0">
                 <a:solidFill>
                   <a:srgbClr val="5A6B87"/>
                 </a:solidFill>
@@ -4294,7 +4336,7 @@
               </a:rPr>
               <a:t>الوجهة والمسار</a:t>
             </a:r>
-            <a:endParaRPr lang="en-US" sz="1250" dirty="0"/>
+            <a:endParaRPr lang="en-US" sz="1150" dirty="0"/>
           </a:p>
         </p:txBody>
       </p:sp>
@@ -4306,8 +4348,8 @@
         </p:nvSpPr>
         <p:spPr>
           <a:xfrm>
-            <a:off x="5547208" y="2743200"/>
-            <a:ext cx="3566160" cy="384048"/>
+            <a:off x="5181448" y="2798064"/>
+            <a:ext cx="3931920" cy="548640"/>
           </a:xfrm>
           <a:prstGeom prst="rect">
             <a:avLst/>
@@ -4320,10 +4362,13 @@
           <a:lstStyle/>
           <a:p>
             <a:pPr rtl="1" algn="r" indent="0" marL="0">
-              <a:buNone/>
-            </a:pPr>
-            <a:r>
-              <a:rPr lang="en-US" sz="1400" b="1" dirty="0">
+              <a:lnSpc>
+                <a:spcPct val="110000"/>
+              </a:lnSpc>
+              <a:buNone/>
+            </a:pPr>
+            <a:r>
+              <a:rPr lang="en-US" sz="1300" b="1" dirty="0">
                 <a:solidFill>
                   <a:srgbClr val="0B1F3A"/>
                 </a:solidFill>
@@ -4333,7 +4378,7 @@
               </a:rPr>
               <a:t>واحة الشعيب — طريق ٤١٢ البري</a:t>
             </a:r>
-            <a:endParaRPr lang="en-US" sz="1400" dirty="0"/>
+            <a:endParaRPr lang="en-US" sz="1300" dirty="0"/>
           </a:p>
         </p:txBody>
       </p:sp>
@@ -4345,8 +4390,8 @@
         </p:nvSpPr>
         <p:spPr>
           <a:xfrm>
-            <a:off x="2895448" y="3218688"/>
-            <a:ext cx="6400800" cy="566928"/>
+            <a:off x="2895448" y="3401568"/>
+            <a:ext cx="6400800" cy="658368"/>
           </a:xfrm>
           <a:prstGeom prst="rect">
             <a:avLst/>
@@ -4365,8 +4410,8 @@
         </p:nvSpPr>
         <p:spPr>
           <a:xfrm>
-            <a:off x="3078328" y="3310128"/>
-            <a:ext cx="2377440" cy="384048"/>
+            <a:off x="3078328" y="3465576"/>
+            <a:ext cx="2103120" cy="274320"/>
           </a:xfrm>
           <a:prstGeom prst="rect">
             <a:avLst/>
@@ -4382,7 +4427,7 @@
               <a:buNone/>
             </a:pPr>
             <a:r>
-              <a:rPr lang="en-US" sz="1250" dirty="0">
+              <a:rPr lang="en-US" sz="1150" dirty="0">
                 <a:solidFill>
                   <a:srgbClr val="5A6B87"/>
                 </a:solidFill>
@@ -4392,7 +4437,7 @@
               </a:rPr>
               <a:t>آخر موقع مستلم</a:t>
             </a:r>
-            <a:endParaRPr lang="en-US" sz="1250" dirty="0"/>
+            <a:endParaRPr lang="en-US" sz="1150" dirty="0"/>
           </a:p>
         </p:txBody>
       </p:sp>
@@ -4404,8 +4449,8 @@
         </p:nvSpPr>
         <p:spPr>
           <a:xfrm>
-            <a:off x="5547208" y="3310128"/>
-            <a:ext cx="3566160" cy="384048"/>
+            <a:off x="5181448" y="3456432"/>
+            <a:ext cx="3931920" cy="548640"/>
           </a:xfrm>
           <a:prstGeom prst="rect">
             <a:avLst/>
@@ -4418,10 +4463,13 @@
           <a:lstStyle/>
           <a:p>
             <a:pPr rtl="1" algn="r" indent="0" marL="0">
-              <a:buNone/>
-            </a:pPr>
-            <a:r>
-              <a:rPr lang="en-US" sz="1400" b="1" dirty="0">
+              <a:lnSpc>
+                <a:spcPct val="110000"/>
+              </a:lnSpc>
+              <a:buNone/>
+            </a:pPr>
+            <a:r>
+              <a:rPr lang="en-US" sz="1300" b="1" dirty="0">
                 <a:solidFill>
                   <a:srgbClr val="0B1F3A"/>
                 </a:solidFill>
@@ -4431,7 +4479,7 @@
               </a:rPr>
               <a:t>على بعد ٣٨ كم من الوجهة — ٥:٢٠ مساءً</a:t>
             </a:r>
-            <a:endParaRPr lang="en-US" sz="1400" dirty="0"/>
+            <a:endParaRPr lang="en-US" sz="1300" dirty="0"/>
           </a:p>
         </p:txBody>
       </p:sp>
@@ -4443,8 +4491,8 @@
         </p:nvSpPr>
         <p:spPr>
           <a:xfrm>
-            <a:off x="3078328" y="3877056"/>
-            <a:ext cx="2377440" cy="384048"/>
+            <a:off x="3078328" y="4123944"/>
+            <a:ext cx="2103120" cy="274320"/>
           </a:xfrm>
           <a:prstGeom prst="rect">
             <a:avLst/>
@@ -4460,7 +4508,7 @@
               <a:buNone/>
             </a:pPr>
             <a:r>
-              <a:rPr lang="en-US" sz="1250" dirty="0">
+              <a:rPr lang="en-US" sz="1150" dirty="0">
                 <a:solidFill>
                   <a:srgbClr val="5A6B87"/>
                 </a:solidFill>
@@ -4470,7 +4518,7 @@
               </a:rPr>
               <a:t>المركبة والركاب</a:t>
             </a:r>
-            <a:endParaRPr lang="en-US" sz="1250" dirty="0"/>
+            <a:endParaRPr lang="en-US" sz="1150" dirty="0"/>
           </a:p>
         </p:txBody>
       </p:sp>
@@ -4482,8 +4530,8 @@
         </p:nvSpPr>
         <p:spPr>
           <a:xfrm>
-            <a:off x="5547208" y="3877056"/>
-            <a:ext cx="3566160" cy="384048"/>
+            <a:off x="5181448" y="4114800"/>
+            <a:ext cx="3931920" cy="548640"/>
           </a:xfrm>
           <a:prstGeom prst="rect">
             <a:avLst/>
@@ -4496,10 +4544,13 @@
           <a:lstStyle/>
           <a:p>
             <a:pPr rtl="1" algn="r" indent="0" marL="0">
-              <a:buNone/>
-            </a:pPr>
-            <a:r>
-              <a:rPr lang="en-US" sz="1400" b="1" dirty="0">
+              <a:lnSpc>
+                <a:spcPct val="110000"/>
+              </a:lnSpc>
+              <a:buNone/>
+            </a:pPr>
+            <a:r>
+              <a:rPr lang="en-US" sz="1300" b="1" dirty="0">
                 <a:solidFill>
                   <a:srgbClr val="0B1F3A"/>
                 </a:solidFill>
@@ -4509,7 +4560,7 @@
               </a:rPr>
               <a:t>دفع رباعي أبيض — ٣ ركاب</a:t>
             </a:r>
-            <a:endParaRPr lang="en-US" sz="1400" dirty="0"/>
+            <a:endParaRPr lang="en-US" sz="1300" dirty="0"/>
           </a:p>
         </p:txBody>
       </p:sp>
@@ -4521,8 +4572,8 @@
         </p:nvSpPr>
         <p:spPr>
           <a:xfrm>
-            <a:off x="2895448" y="4352544"/>
-            <a:ext cx="6400800" cy="566928"/>
+            <a:off x="2895448" y="4718304"/>
+            <a:ext cx="6400800" cy="658368"/>
           </a:xfrm>
           <a:prstGeom prst="rect">
             <a:avLst/>
@@ -4541,8 +4592,8 @@
         </p:nvSpPr>
         <p:spPr>
           <a:xfrm>
-            <a:off x="3078328" y="4443984"/>
-            <a:ext cx="2377440" cy="384048"/>
+            <a:off x="3078328" y="4782312"/>
+            <a:ext cx="2103120" cy="274320"/>
           </a:xfrm>
           <a:prstGeom prst="rect">
             <a:avLst/>
@@ -4558,7 +4609,7 @@
               <a:buNone/>
             </a:pPr>
             <a:r>
-              <a:rPr lang="en-US" sz="1250" dirty="0">
+              <a:rPr lang="en-US" sz="1150" dirty="0">
                 <a:solidFill>
                   <a:srgbClr val="5A6B87"/>
                 </a:solidFill>
@@ -4568,7 +4619,7 @@
               </a:rPr>
               <a:t>جهة الاتصال</a:t>
             </a:r>
-            <a:endParaRPr lang="en-US" sz="1250" dirty="0"/>
+            <a:endParaRPr lang="en-US" sz="1150" dirty="0"/>
           </a:p>
         </p:txBody>
       </p:sp>
@@ -4580,8 +4631,8 @@
         </p:nvSpPr>
         <p:spPr>
           <a:xfrm>
-            <a:off x="5547208" y="4443984"/>
-            <a:ext cx="3566160" cy="384048"/>
+            <a:off x="5181448" y="4773168"/>
+            <a:ext cx="3931920" cy="548640"/>
           </a:xfrm>
           <a:prstGeom prst="rect">
             <a:avLst/>
@@ -4594,10 +4645,13 @@
           <a:lstStyle/>
           <a:p>
             <a:pPr rtl="1" algn="r" indent="0" marL="0">
-              <a:buNone/>
-            </a:pPr>
-            <a:r>
-              <a:rPr lang="en-US" sz="1400" b="1" dirty="0">
+              <a:lnSpc>
+                <a:spcPct val="110000"/>
+              </a:lnSpc>
+              <a:buNone/>
+            </a:pPr>
+            <a:r>
+              <a:rPr lang="en-US" sz="1300" b="1" dirty="0">
                 <a:solidFill>
                   <a:srgbClr val="0B1F3A"/>
                 </a:solidFill>
@@ -4607,7 +4661,7 @@
               </a:rPr>
               <a:t>سالم العتيبي — ٠٥xxxxxxxx</a:t>
             </a:r>
-            <a:endParaRPr lang="en-US" sz="1400" dirty="0"/>
+            <a:endParaRPr lang="en-US" sz="1300" dirty="0"/>
           </a:p>
         </p:txBody>
       </p:sp>
@@ -4619,7 +4673,7 @@
         </p:nvSpPr>
         <p:spPr>
           <a:xfrm>
-            <a:off x="7101688" y="5084064"/>
+            <a:off x="7101688" y="5468112"/>
             <a:ext cx="2011680" cy="457200"/>
           </a:xfrm>
           <a:prstGeom prst="roundRect">
@@ -4641,7 +4695,7 @@
         </p:nvSpPr>
         <p:spPr>
           <a:xfrm>
-            <a:off x="7101688" y="5084064"/>
+            <a:off x="7101688" y="5468112"/>
             <a:ext cx="2011680" cy="457200"/>
           </a:xfrm>
           <a:prstGeom prst="rect">
@@ -4680,7 +4734,7 @@
         </p:nvSpPr>
         <p:spPr>
           <a:xfrm>
-            <a:off x="2712568" y="1280160"/>
+            <a:off x="2712568" y="1444752"/>
             <a:ext cx="2377440" cy="365760"/>
           </a:xfrm>
           <a:prstGeom prst="roundRect">
@@ -4702,7 +4756,7 @@
         </p:nvSpPr>
         <p:spPr>
           <a:xfrm>
-            <a:off x="2712568" y="1280160"/>
+            <a:off x="2712568" y="1444752"/>
             <a:ext cx="2377440" cy="365760"/>
           </a:xfrm>
           <a:prstGeom prst="rect">
@@ -4813,6 +4867,9 @@
       </p:sp>
     </p:spTree>
   </p:cSld>
+  <p:transition spd="med">
+    <p:fade/>
+  </p:transition>
   <p:clrMapOvr>
     <a:masterClrMapping/>
   </p:clrMapOvr>
@@ -5879,6 +5936,9 @@
       </p:sp>
     </p:spTree>
   </p:cSld>
+  <p:transition spd="med">
+    <p:fade/>
+  </p:transition>
   <p:clrMapOvr>
     <a:masterClrMapping/>
   </p:clrMapOvr>
@@ -6751,6 +6811,9 @@
       </p:sp>
     </p:spTree>
   </p:cSld>
+  <p:transition spd="med">
+    <p:fade/>
+  </p:transition>
   <p:clrMapOvr>
     <a:masterClrMapping/>
   </p:clrMapOvr>

</xml_diff>